<commit_message>
bench: add alignment visuals to the picture-first deck (how reads/copies align)
Two real-data alignment figures answer "how do we align" for both relations:
- fig4_align: a real multimapper read aligned to two array copies — de = 0.0187 vs
  0.0180 (mismatch ticks, real counts), |diff| 0.0007 <= Delta => TIED. Shows where
  de comes from (minimap2 gap-compressed divergence) and what a ~R "tie" is.
- fig5_dotplot: 12-mer dot-plots of the copy models — two array copies show a full
  diagonal (backbone ~99%, ~B ok); OCLN vs SEPTIN7 is empty (no diagonal, cov 0.05,
  ~B fails). Shows how ~B / reciprocal coverage is measured.
Deck now 7 picture-first slides: title, reads(~R), read-alignment(de/tie), exon-union,
copy-dotplot(~B), graph(family vs bridge), definition.

Co-Authored-By: Claude Opus 4.8 (1M context) <noreply@anthropic.com>
Claude-Session: https://claude.ai/code/session_01BwQ1eLGAdbthqL2ALyxxXu
</commit_message>
<xml_diff>
--- a/bench/family_definition_visual.pptx
+++ b/bench/family_definition_visual.pptx
@@ -10,6 +10,8 @@
     <p:sldId id="258" r:id="rId9"/>
     <p:sldId id="259" r:id="rId10"/>
     <p:sldId id="260" r:id="rId11"/>
+    <p:sldId id="261" r:id="rId12"/>
+    <p:sldId id="262" r:id="rId13"/>
   </p:sldIdLst>
   <p:sldSz cx="12188952" cy="6858000" type="screen4x3"/>
   <p:notesSz cx="6858000" cy="9144000"/>
@@ -3311,6 +3313,118 @@
               </a:defRPr>
             </a:pPr>
             <a:r>
+              <a:t>How a read aligns: the number 'de', and what a 'tie' is</a:t>
+            </a:r>
+          </a:p>
+        </p:txBody>
+      </p:sp>
+      <p:pic>
+        <p:nvPicPr>
+          <p:cNvPr id="3" name="Picture 2" descr="fig4_align.png"/>
+          <p:cNvPicPr>
+            <a:picLocks noChangeAspect="1"/>
+          </p:cNvPicPr>
+          <p:nvPr/>
+        </p:nvPicPr>
+        <p:blipFill>
+          <a:blip r:embed="rId2"/>
+          <a:stretch>
+            <a:fillRect/>
+          </a:stretch>
+        </p:blipFill>
+        <p:spPr>
+          <a:xfrm>
+            <a:off x="425196" y="914400"/>
+            <a:ext cx="11338560" cy="4023797"/>
+          </a:xfrm>
+          <a:prstGeom prst="rect">
+            <a:avLst/>
+          </a:prstGeom>
+        </p:spPr>
+      </p:pic>
+      <p:sp>
+        <p:nvSpPr>
+          <p:cNvPr id="4" name="TextBox 3"/>
+          <p:cNvSpPr txBox="1"/>
+          <p:nvPr/>
+        </p:nvSpPr>
+        <p:spPr>
+          <a:xfrm>
+            <a:off x="548640" y="6080760"/>
+            <a:ext cx="11064240" cy="640080"/>
+          </a:xfrm>
+          <a:prstGeom prst="rect">
+            <a:avLst/>
+          </a:prstGeom>
+          <a:noFill/>
+        </p:spPr>
+        <p:txBody>
+          <a:bodyPr wrap="square">
+            <a:spAutoFit/>
+          </a:bodyPr>
+          <a:lstStyle/>
+          <a:p>
+            <a:pPr algn="ctr">
+              <a:defRPr sz="1500" b="1">
+                <a:solidFill>
+                  <a:srgbClr val="D96B27"/>
+                </a:solidFill>
+              </a:defRPr>
+            </a:pPr>
+            <a:r>
+              <a:t>minimap2 aligns the read to each copy; de = differences per base. Two copies within Δ of each other = a tie = one ~R vote.</a:t>
+            </a:r>
+          </a:p>
+        </p:txBody>
+      </p:sp>
+    </p:spTree>
+  </p:cSld>
+  <p:clrMapOvr>
+    <a:masterClrMapping/>
+  </p:clrMapOvr>
+</p:sld>
+</file>
+
+<file path=ppt/slides/slide4.xml><?xml version="1.0" encoding="utf-8"?>
+<p:sld xmlns:a="http://schemas.openxmlformats.org/drawingml/2006/main" xmlns:p="http://schemas.openxmlformats.org/presentationml/2006/main" xmlns:r="http://schemas.openxmlformats.org/officeDocument/2006/relationships">
+  <p:cSld>
+    <p:spTree>
+      <p:nvGrpSpPr>
+        <p:cNvPr id="1" name=""/>
+        <p:cNvGrpSpPr/>
+        <p:nvPr/>
+      </p:nvGrpSpPr>
+      <p:grpSpPr/>
+      <p:sp>
+        <p:nvSpPr>
+          <p:cNvPr id="2" name="TextBox 1"/>
+          <p:cNvSpPr txBox="1"/>
+          <p:nvPr/>
+        </p:nvSpPr>
+        <p:spPr>
+          <a:xfrm>
+            <a:off x="457200" y="164592"/>
+            <a:ext cx="11247120" cy="640080"/>
+          </a:xfrm>
+          <a:prstGeom prst="rect">
+            <a:avLst/>
+          </a:prstGeom>
+          <a:noFill/>
+        </p:spPr>
+        <p:txBody>
+          <a:bodyPr wrap="none">
+            <a:spAutoFit/>
+          </a:bodyPr>
+          <a:lstStyle/>
+          <a:p>
+            <a:pPr>
+              <a:defRPr sz="2400" b="1">
+                <a:solidFill>
+                  <a:srgbClr val="1F2D5A"/>
+                </a:solidFill>
+              </a:defRPr>
+            </a:pPr>
+            <a:r>
               <a:t>Sum the exons of all isoforms  →  one copy model</a:t>
             </a:r>
           </a:p>
@@ -3383,7 +3497,119 @@
 </p:sld>
 </file>
 
-<file path=ppt/slides/slide4.xml><?xml version="1.0" encoding="utf-8"?>
+<file path=ppt/slides/slide5.xml><?xml version="1.0" encoding="utf-8"?>
+<p:sld xmlns:a="http://schemas.openxmlformats.org/drawingml/2006/main" xmlns:p="http://schemas.openxmlformats.org/presentationml/2006/main" xmlns:r="http://schemas.openxmlformats.org/officeDocument/2006/relationships">
+  <p:cSld>
+    <p:spTree>
+      <p:nvGrpSpPr>
+        <p:cNvPr id="1" name=""/>
+        <p:cNvGrpSpPr/>
+        <p:nvPr/>
+      </p:nvGrpSpPr>
+      <p:grpSpPr/>
+      <p:sp>
+        <p:nvSpPr>
+          <p:cNvPr id="2" name="TextBox 1"/>
+          <p:cNvSpPr txBox="1"/>
+          <p:nvPr/>
+        </p:nvSpPr>
+        <p:spPr>
+          <a:xfrm>
+            <a:off x="457200" y="164592"/>
+            <a:ext cx="11247120" cy="640080"/>
+          </a:xfrm>
+          <a:prstGeom prst="rect">
+            <a:avLst/>
+          </a:prstGeom>
+          <a:noFill/>
+        </p:spPr>
+        <p:txBody>
+          <a:bodyPr wrap="none">
+            <a:spAutoFit/>
+          </a:bodyPr>
+          <a:lstStyle/>
+          <a:p>
+            <a:pPr>
+              <a:defRPr sz="2400" b="1">
+                <a:solidFill>
+                  <a:srgbClr val="1F2D5A"/>
+                </a:solidFill>
+              </a:defRPr>
+            </a:pPr>
+            <a:r>
+              <a:t>How we align the copies: a dot-plot  →  backbone or not (~B)</a:t>
+            </a:r>
+          </a:p>
+        </p:txBody>
+      </p:sp>
+      <p:pic>
+        <p:nvPicPr>
+          <p:cNvPr id="3" name="Picture 2" descr="fig5_dotplot.png"/>
+          <p:cNvPicPr>
+            <a:picLocks noChangeAspect="1"/>
+          </p:cNvPicPr>
+          <p:nvPr/>
+        </p:nvPicPr>
+        <p:blipFill>
+          <a:blip r:embed="rId2"/>
+          <a:stretch>
+            <a:fillRect/>
+          </a:stretch>
+        </p:blipFill>
+        <p:spPr>
+          <a:xfrm>
+            <a:off x="615051" y="914400"/>
+            <a:ext cx="10958850" cy="4892040"/>
+          </a:xfrm>
+          <a:prstGeom prst="rect">
+            <a:avLst/>
+          </a:prstGeom>
+        </p:spPr>
+      </p:pic>
+      <p:sp>
+        <p:nvSpPr>
+          <p:cNvPr id="4" name="TextBox 3"/>
+          <p:cNvSpPr txBox="1"/>
+          <p:nvPr/>
+        </p:nvSpPr>
+        <p:spPr>
+          <a:xfrm>
+            <a:off x="548640" y="6080760"/>
+            <a:ext cx="11064240" cy="640080"/>
+          </a:xfrm>
+          <a:prstGeom prst="rect">
+            <a:avLst/>
+          </a:prstGeom>
+          <a:noFill/>
+        </p:spPr>
+        <p:txBody>
+          <a:bodyPr wrap="square">
+            <a:spAutoFit/>
+          </a:bodyPr>
+          <a:lstStyle/>
+          <a:p>
+            <a:pPr algn="ctr">
+              <a:defRPr sz="1500" b="1">
+                <a:solidFill>
+                  <a:srgbClr val="D96B27"/>
+                </a:solidFill>
+              </a:defRPr>
+            </a:pPr>
+            <a:r>
+              <a:t>Align the copy models to each other; a diagonal = a shared backbone over most of both. Bridge: no diagonal → ~B fails.</a:t>
+            </a:r>
+          </a:p>
+        </p:txBody>
+      </p:sp>
+    </p:spTree>
+  </p:cSld>
+  <p:clrMapOvr>
+    <a:masterClrMapping/>
+  </p:clrMapOvr>
+</p:sld>
+</file>
+
+<file path=ppt/slides/slide6.xml><?xml version="1.0" encoding="utf-8"?>
 <p:sld xmlns:a="http://schemas.openxmlformats.org/drawingml/2006/main" xmlns:p="http://schemas.openxmlformats.org/presentationml/2006/main" xmlns:r="http://schemas.openxmlformats.org/officeDocument/2006/relationships">
   <p:cSld>
     <p:spTree>
@@ -3495,7 +3721,7 @@
 </p:sld>
 </file>
 
-<file path=ppt/slides/slide5.xml><?xml version="1.0" encoding="utf-8"?>
+<file path=ppt/slides/slide7.xml><?xml version="1.0" encoding="utf-8"?>
 <p:sld xmlns:a="http://schemas.openxmlformats.org/drawingml/2006/main" xmlns:p="http://schemas.openxmlformats.org/presentationml/2006/main" xmlns:r="http://schemas.openxmlformats.org/officeDocument/2006/relationships">
   <p:cSld>
     <p:spTree>

</xml_diff>

<commit_message>
bench: per-copy coordinate results table + clarify the two distinct alignments
- fig9_results redesigned: every found copy with its full coordinates (chrom:start-end)
  — RABL2A/RABL2B, AK6/LOC115934278, CCDC196/LOC129526440, and the 4 MAGEA de-novo
  locus pairs — with tied-read evidence and P=R=1.00; rejected summary + DNA context.
- fig5 caption clarifies: the copy-vs-copy backbone is a SEPARATE minimap2 -cx asm20 run
  on the copy exon-union sequences, NOT the read 'de' tag (which is the read->genome
  alignment feeding ~R). Two distinct alignments.
- consolidated decks back to canonical family_definition_visual.pptx (12 slides);
  removed stale _FULL/_v3.

Co-Authored-By: Claude Opus 4.8 (1M context) <noreply@anthropic.com>
Claude-Session: https://claude.ai/code/session_01BwQ1eLGAdbthqL2ALyxxXu
</commit_message>
<xml_diff>
--- a/bench/family_definition_visual.pptx
+++ b/bench/family_definition_visual.pptx
@@ -12,6 +12,11 @@
     <p:sldId id="260" r:id="rId11"/>
     <p:sldId id="261" r:id="rId12"/>
     <p:sldId id="262" r:id="rId13"/>
+    <p:sldId id="263" r:id="rId14"/>
+    <p:sldId id="264" r:id="rId15"/>
+    <p:sldId id="265" r:id="rId16"/>
+    <p:sldId id="266" r:id="rId17"/>
+    <p:sldId id="267" r:id="rId18"/>
   </p:sldIdLst>
   <p:sldSz cx="12188952" cy="6858000" type="screen4x3"/>
   <p:notesSz cx="6858000" cy="9144000"/>
@@ -3161,6 +3166,342 @@
 </p:sld>
 </file>
 
+<file path=ppt/slides/slide10.xml><?xml version="1.0" encoding="utf-8"?>
+<p:sld xmlns:a="http://schemas.openxmlformats.org/drawingml/2006/main" xmlns:p="http://schemas.openxmlformats.org/presentationml/2006/main" xmlns:r="http://schemas.openxmlformats.org/officeDocument/2006/relationships">
+  <p:cSld>
+    <p:spTree>
+      <p:nvGrpSpPr>
+        <p:cNvPr id="1" name=""/>
+        <p:cNvGrpSpPr/>
+        <p:nvPr/>
+      </p:nvGrpSpPr>
+      <p:grpSpPr/>
+      <p:sp>
+        <p:nvSpPr>
+          <p:cNvPr id="2" name="TextBox 1"/>
+          <p:cNvSpPr txBox="1"/>
+          <p:nvPr/>
+        </p:nvSpPr>
+        <p:spPr>
+          <a:xfrm>
+            <a:off x="457200" y="164592"/>
+            <a:ext cx="11247120" cy="640080"/>
+          </a:xfrm>
+          <a:prstGeom prst="rect">
+            <a:avLst/>
+          </a:prstGeom>
+          <a:noFill/>
+        </p:spPr>
+        <p:txBody>
+          <a:bodyPr wrap="none">
+            <a:spAutoFit/>
+          </a:bodyPr>
+          <a:lstStyle/>
+          <a:p>
+            <a:pPr>
+              <a:defRPr sz="2400" b="1">
+                <a:solidFill>
+                  <a:srgbClr val="1F2D5A"/>
+                </a:solidFill>
+              </a:defRPr>
+            </a:pPr>
+            <a:r>
+              <a:t>How the alignment works (minimap2's job, not ours; not Needleman–Wunsch)</a:t>
+            </a:r>
+          </a:p>
+        </p:txBody>
+      </p:sp>
+      <p:pic>
+        <p:nvPicPr>
+          <p:cNvPr id="3" name="Picture 2" descr="fig6_algo.png"/>
+          <p:cNvPicPr>
+            <a:picLocks noChangeAspect="1"/>
+          </p:cNvPicPr>
+          <p:nvPr/>
+        </p:nvPicPr>
+        <p:blipFill>
+          <a:blip r:embed="rId2"/>
+          <a:stretch>
+            <a:fillRect/>
+          </a:stretch>
+        </p:blipFill>
+        <p:spPr>
+          <a:xfrm>
+            <a:off x="425196" y="914400"/>
+            <a:ext cx="11338560" cy="4046663"/>
+          </a:xfrm>
+          <a:prstGeom prst="rect">
+            <a:avLst/>
+          </a:prstGeom>
+        </p:spPr>
+      </p:pic>
+      <p:sp>
+        <p:nvSpPr>
+          <p:cNvPr id="4" name="TextBox 3"/>
+          <p:cNvSpPr txBox="1"/>
+          <p:nvPr/>
+        </p:nvSpPr>
+        <p:spPr>
+          <a:xfrm>
+            <a:off x="548640" y="6080760"/>
+            <a:ext cx="11064240" cy="640080"/>
+          </a:xfrm>
+          <a:prstGeom prst="rect">
+            <a:avLst/>
+          </a:prstGeom>
+          <a:noFill/>
+        </p:spPr>
+        <p:txBody>
+          <a:bodyPr wrap="square">
+            <a:spAutoFit/>
+          </a:bodyPr>
+          <a:lstStyle/>
+          <a:p>
+            <a:pPr algn="ctr">
+              <a:defRPr sz="1500" b="1">
+                <a:solidFill>
+                  <a:srgbClr val="D96B27"/>
+                </a:solidFill>
+              </a:defRPr>
+            </a:pPr>
+            <a:r>
+              <a:t>minimap2 — not us — does seed–chain–align (minimizer seeds → chaining → banded affine-gap DP). We only consume its output.</a:t>
+            </a:r>
+          </a:p>
+        </p:txBody>
+      </p:sp>
+    </p:spTree>
+  </p:cSld>
+  <p:clrMapOvr>
+    <a:masterClrMapping/>
+  </p:clrMapOvr>
+</p:sld>
+</file>
+
+<file path=ppt/slides/slide11.xml><?xml version="1.0" encoding="utf-8"?>
+<p:sld xmlns:a="http://schemas.openxmlformats.org/drawingml/2006/main" xmlns:p="http://schemas.openxmlformats.org/presentationml/2006/main" xmlns:r="http://schemas.openxmlformats.org/officeDocument/2006/relationships">
+  <p:cSld>
+    <p:spTree>
+      <p:nvGrpSpPr>
+        <p:cNvPr id="1" name=""/>
+        <p:cNvGrpSpPr/>
+        <p:nvPr/>
+      </p:nvGrpSpPr>
+      <p:grpSpPr/>
+      <p:sp>
+        <p:nvSpPr>
+          <p:cNvPr id="2" name="TextBox 1"/>
+          <p:cNvSpPr txBox="1"/>
+          <p:nvPr/>
+        </p:nvSpPr>
+        <p:spPr>
+          <a:xfrm>
+            <a:off x="457200" y="164592"/>
+            <a:ext cx="11247120" cy="640080"/>
+          </a:xfrm>
+          <a:prstGeom prst="rect">
+            <a:avLst/>
+          </a:prstGeom>
+          <a:noFill/>
+        </p:spPr>
+        <p:txBody>
+          <a:bodyPr wrap="none">
+            <a:spAutoFit/>
+          </a:bodyPr>
+          <a:lstStyle/>
+          <a:p>
+            <a:pPr>
+              <a:defRPr sz="2400" b="1">
+                <a:solidFill>
+                  <a:srgbClr val="1F2D5A"/>
+                </a:solidFill>
+              </a:defRPr>
+            </a:pPr>
+            <a:r>
+              <a:t>Error or real? — by recurrence across reads</a:t>
+            </a:r>
+          </a:p>
+        </p:txBody>
+      </p:sp>
+      <p:pic>
+        <p:nvPicPr>
+          <p:cNvPr id="3" name="Picture 2" descr="fig7_error.png"/>
+          <p:cNvPicPr>
+            <a:picLocks noChangeAspect="1"/>
+          </p:cNvPicPr>
+          <p:nvPr/>
+        </p:nvPicPr>
+        <p:blipFill>
+          <a:blip r:embed="rId2"/>
+          <a:stretch>
+            <a:fillRect/>
+          </a:stretch>
+        </p:blipFill>
+        <p:spPr>
+          <a:xfrm>
+            <a:off x="425196" y="914400"/>
+            <a:ext cx="11338560" cy="3732541"/>
+          </a:xfrm>
+          <a:prstGeom prst="rect">
+            <a:avLst/>
+          </a:prstGeom>
+        </p:spPr>
+      </p:pic>
+      <p:sp>
+        <p:nvSpPr>
+          <p:cNvPr id="4" name="TextBox 3"/>
+          <p:cNvSpPr txBox="1"/>
+          <p:nvPr/>
+        </p:nvSpPr>
+        <p:spPr>
+          <a:xfrm>
+            <a:off x="548640" y="6080760"/>
+            <a:ext cx="11064240" cy="640080"/>
+          </a:xfrm>
+          <a:prstGeom prst="rect">
+            <a:avLst/>
+          </a:prstGeom>
+          <a:noFill/>
+        </p:spPr>
+        <p:txBody>
+          <a:bodyPr wrap="square">
+            <a:spAutoFit/>
+          </a:bodyPr>
+          <a:lstStyle/>
+          <a:p>
+            <a:pPr algn="ctr">
+              <a:defRPr sz="1500" b="1">
+                <a:solidFill>
+                  <a:srgbClr val="D96B27"/>
+                </a:solidFill>
+              </a:defRPr>
+            </a:pPr>
+            <a:r>
+              <a:t>A difference in one read = error (ignored); the same difference in many reads = a real variant. Edges need a quorum (k≥3).</a:t>
+            </a:r>
+          </a:p>
+        </p:txBody>
+      </p:sp>
+    </p:spTree>
+  </p:cSld>
+  <p:clrMapOvr>
+    <a:masterClrMapping/>
+  </p:clrMapOvr>
+</p:sld>
+</file>
+
+<file path=ppt/slides/slide12.xml><?xml version="1.0" encoding="utf-8"?>
+<p:sld xmlns:a="http://schemas.openxmlformats.org/drawingml/2006/main" xmlns:p="http://schemas.openxmlformats.org/presentationml/2006/main" xmlns:r="http://schemas.openxmlformats.org/officeDocument/2006/relationships">
+  <p:cSld>
+    <p:spTree>
+      <p:nvGrpSpPr>
+        <p:cNvPr id="1" name=""/>
+        <p:cNvGrpSpPr/>
+        <p:nvPr/>
+      </p:nvGrpSpPr>
+      <p:grpSpPr/>
+      <p:sp>
+        <p:nvSpPr>
+          <p:cNvPr id="2" name="TextBox 1"/>
+          <p:cNvSpPr txBox="1"/>
+          <p:nvPr/>
+        </p:nvSpPr>
+        <p:spPr>
+          <a:xfrm>
+            <a:off x="457200" y="164592"/>
+            <a:ext cx="11247120" cy="640080"/>
+          </a:xfrm>
+          <a:prstGeom prst="rect">
+            <a:avLst/>
+          </a:prstGeom>
+          <a:noFill/>
+        </p:spPr>
+        <p:txBody>
+          <a:bodyPr wrap="none">
+            <a:spAutoFit/>
+          </a:bodyPr>
+          <a:lstStyle/>
+          <a:p>
+            <a:pPr>
+              <a:defRPr sz="2400" b="1">
+                <a:solidFill>
+                  <a:srgbClr val="1F2D5A"/>
+                </a:solidFill>
+              </a:defRPr>
+            </a:pPr>
+            <a:r>
+              <a:t>Digesting a read into exons (CIGAR → exons → union)</a:t>
+            </a:r>
+          </a:p>
+        </p:txBody>
+      </p:sp>
+      <p:pic>
+        <p:nvPicPr>
+          <p:cNvPr id="3" name="Picture 2" descr="fig8_cigar.png"/>
+          <p:cNvPicPr>
+            <a:picLocks noChangeAspect="1"/>
+          </p:cNvPicPr>
+          <p:nvPr/>
+        </p:nvPicPr>
+        <p:blipFill>
+          <a:blip r:embed="rId2"/>
+          <a:stretch>
+            <a:fillRect/>
+          </a:stretch>
+        </p:blipFill>
+        <p:spPr>
+          <a:xfrm>
+            <a:off x="425196" y="914400"/>
+            <a:ext cx="11338560" cy="4320729"/>
+          </a:xfrm>
+          <a:prstGeom prst="rect">
+            <a:avLst/>
+          </a:prstGeom>
+        </p:spPr>
+      </p:pic>
+      <p:sp>
+        <p:nvSpPr>
+          <p:cNvPr id="4" name="TextBox 3"/>
+          <p:cNvSpPr txBox="1"/>
+          <p:nvPr/>
+        </p:nvSpPr>
+        <p:spPr>
+          <a:xfrm>
+            <a:off x="548640" y="6080760"/>
+            <a:ext cx="11064240" cy="640080"/>
+          </a:xfrm>
+          <a:prstGeom prst="rect">
+            <a:avLst/>
+          </a:prstGeom>
+          <a:noFill/>
+        </p:spPr>
+        <p:txBody>
+          <a:bodyPr wrap="square">
+            <a:spAutoFit/>
+          </a:bodyPr>
+          <a:lstStyle/>
+          <a:p>
+            <a:pPr algn="ctr">
+              <a:defRPr sz="1500" b="1">
+                <a:solidFill>
+                  <a:srgbClr val="D96B27"/>
+                </a:solidFill>
+              </a:defRPr>
+            </a:pPr>
+            <a:r>
+              <a:t>Each read's CIGAR marks exons (M) and introns (N); junctions are trusted by recurrence + canonical GT–AG; exons are then unioned.</a:t>
+            </a:r>
+          </a:p>
+        </p:txBody>
+      </p:sp>
+    </p:spTree>
+  </p:cSld>
+  <p:clrMapOvr>
+    <a:masterClrMapping/>
+  </p:clrMapOvr>
+</p:sld>
+</file>
+
 <file path=ppt/slides/slide2.xml><?xml version="1.0" encoding="utf-8"?>
 <p:sld xmlns:a="http://schemas.openxmlformats.org/drawingml/2006/main" xmlns:p="http://schemas.openxmlformats.org/presentationml/2006/main" xmlns:r="http://schemas.openxmlformats.org/officeDocument/2006/relationships">
   <p:cSld>
@@ -3537,7 +3878,7 @@
               </a:defRPr>
             </a:pPr>
             <a:r>
-              <a:t>How we align the copies: a dot-plot  →  backbone or not (~B)</a:t>
+              <a:t>Aligning the copies: a dot-plot  →  backbone or not (~B)</a:t>
             </a:r>
           </a:p>
         </p:txBody>
@@ -3596,7 +3937,7 @@
               </a:defRPr>
             </a:pPr>
             <a:r>
-              <a:t>Align the copy models to each other; a diagonal = a shared backbone over most of both. Bridge: no diagonal → ~B fails.</a:t>
+              <a:t>A SECOND, separate minimap2 run aligns copy-vs-copy (not the read 'de' tag): diagonal = shared backbone (~B ✓); bridge = none (~B ✗).</a:t>
             </a:r>
           </a:p>
         </p:txBody>
@@ -3842,6 +4183,195 @@
             </a:pPr>
             <a:r>
               <a:t>Built only from reads:  align → loci → count ties → ~R graph → components → exon-union copies → align → ~B → family.</a:t>
+            </a:r>
+          </a:p>
+        </p:txBody>
+      </p:sp>
+    </p:spTree>
+  </p:cSld>
+  <p:clrMapOvr>
+    <a:masterClrMapping/>
+  </p:clrMapOvr>
+</p:sld>
+</file>
+
+<file path=ppt/slides/slide8.xml><?xml version="1.0" encoding="utf-8"?>
+<p:sld xmlns:a="http://schemas.openxmlformats.org/drawingml/2006/main" xmlns:p="http://schemas.openxmlformats.org/presentationml/2006/main" xmlns:r="http://schemas.openxmlformats.org/officeDocument/2006/relationships">
+  <p:cSld>
+    <p:spTree>
+      <p:nvGrpSpPr>
+        <p:cNvPr id="1" name=""/>
+        <p:cNvGrpSpPr/>
+        <p:nvPr/>
+      </p:nvGrpSpPr>
+      <p:grpSpPr/>
+      <p:sp>
+        <p:nvSpPr>
+          <p:cNvPr id="2" name="TextBox 1"/>
+          <p:cNvSpPr txBox="1"/>
+          <p:nvPr/>
+        </p:nvSpPr>
+        <p:spPr>
+          <a:xfrm>
+            <a:off x="457200" y="164592"/>
+            <a:ext cx="11247120" cy="640080"/>
+          </a:xfrm>
+          <a:prstGeom prst="rect">
+            <a:avLst/>
+          </a:prstGeom>
+          <a:noFill/>
+        </p:spPr>
+        <p:txBody>
+          <a:bodyPr wrap="none">
+            <a:spAutoFit/>
+          </a:bodyPr>
+          <a:lstStyle/>
+          <a:p>
+            <a:pPr>
+              <a:defRPr sz="2400" b="1">
+                <a:solidFill>
+                  <a:srgbClr val="1F2D5A"/>
+                </a:solidFill>
+              </a:defRPr>
+            </a:pPr>
+            <a:r>
+              <a:t>Results: gene families found  (precision / recall)</a:t>
+            </a:r>
+          </a:p>
+        </p:txBody>
+      </p:sp>
+      <p:pic>
+        <p:nvPicPr>
+          <p:cNvPr id="3" name="Picture 2" descr="fig9_results.png"/>
+          <p:cNvPicPr>
+            <a:picLocks noChangeAspect="1"/>
+          </p:cNvPicPr>
+          <p:nvPr/>
+        </p:nvPicPr>
+        <p:blipFill>
+          <a:blip r:embed="rId2"/>
+          <a:stretch>
+            <a:fillRect/>
+          </a:stretch>
+        </p:blipFill>
+        <p:spPr>
+          <a:xfrm>
+            <a:off x="2234656" y="914400"/>
+            <a:ext cx="7719639" cy="4892040"/>
+          </a:xfrm>
+          <a:prstGeom prst="rect">
+            <a:avLst/>
+          </a:prstGeom>
+        </p:spPr>
+      </p:pic>
+      <p:sp>
+        <p:nvSpPr>
+          <p:cNvPr id="4" name="TextBox 3"/>
+          <p:cNvSpPr txBox="1"/>
+          <p:nvPr/>
+        </p:nvSpPr>
+        <p:spPr>
+          <a:xfrm>
+            <a:off x="548640" y="6080760"/>
+            <a:ext cx="11064240" cy="640080"/>
+          </a:xfrm>
+          <a:prstGeom prst="rect">
+            <a:avLst/>
+          </a:prstGeom>
+          <a:noFill/>
+        </p:spPr>
+        <p:txBody>
+          <a:bodyPr wrap="square">
+            <a:spAutoFit/>
+          </a:bodyPr>
+          <a:lstStyle/>
+          <a:p>
+            <a:pPr algn="ctr">
+              <a:defRPr sz="1500" b="1">
+                <a:solidFill>
+                  <a:srgbClr val="D96B27"/>
+                </a:solidFill>
+              </a:defRPr>
+            </a:pPr>
+            <a:r>
+              <a:t>On the 17-candidate panel with hand-checked ground truth: precision = recall = 1.00 (0 false families, 0 missed).</a:t>
+            </a:r>
+          </a:p>
+        </p:txBody>
+      </p:sp>
+    </p:spTree>
+  </p:cSld>
+  <p:clrMapOvr>
+    <a:masterClrMapping/>
+  </p:clrMapOvr>
+</p:sld>
+</file>
+
+<file path=ppt/slides/slide9.xml><?xml version="1.0" encoding="utf-8"?>
+<p:sld xmlns:a="http://schemas.openxmlformats.org/drawingml/2006/main" xmlns:p="http://schemas.openxmlformats.org/presentationml/2006/main" xmlns:r="http://schemas.openxmlformats.org/officeDocument/2006/relationships">
+  <p:cSld>
+    <p:spTree>
+      <p:nvGrpSpPr>
+        <p:cNvPr id="1" name=""/>
+        <p:cNvGrpSpPr/>
+        <p:nvPr/>
+      </p:nvGrpSpPr>
+      <p:grpSpPr/>
+      <p:sp>
+        <p:nvSpPr>
+          <p:cNvPr id="2" name="TextBox 1"/>
+          <p:cNvSpPr txBox="1"/>
+          <p:nvPr/>
+        </p:nvSpPr>
+        <p:spPr>
+          <a:xfrm>
+            <a:off x="731520" y="2286000"/>
+            <a:ext cx="10698480" cy="2286000"/>
+          </a:xfrm>
+          <a:prstGeom prst="rect">
+            <a:avLst/>
+          </a:prstGeom>
+          <a:noFill/>
+        </p:spPr>
+        <p:txBody>
+          <a:bodyPr wrap="square">
+            <a:spAutoFit/>
+          </a:bodyPr>
+          <a:lstStyle/>
+          <a:p>
+            <a:pPr>
+              <a:defRPr sz="3400" b="1">
+                <a:solidFill>
+                  <a:srgbClr val="1F2D5A"/>
+                </a:solidFill>
+              </a:defRPr>
+            </a:pPr>
+            <a:r>
+              <a:t>Appendix — how it actually works</a:t>
+            </a:r>
+          </a:p>
+          <a:p>
+            <a:pPr>
+              <a:defRPr sz="1700">
+                <a:solidFill>
+                  <a:srgbClr val="555555"/>
+                </a:solidFill>
+              </a:defRPr>
+            </a:pPr>
+            <a:r>
+              <a:t>the alignment algorithm &amp; scoring · error vs. real difference · digesting a read into exons</a:t>
+            </a:r>
+          </a:p>
+          <a:p>
+            <a:pPr>
+              <a:defRPr sz="1300" b="1">
+                <a:solidFill>
+                  <a:srgbClr val="D96B27"/>
+                </a:solidFill>
+              </a:defRPr>
+            </a:pPr>
+            <a:r>
+              <a:t>What is minimap2's vs ours:  minimap2 does the ALIGNMENT (reads → placements, de, CIGAR — we do not implement an aligner). Our method is everything downstream — the two relations, the graph, the definition.</a:t>
             </a:r>
           </a:p>
         </p:txBody>

</xml_diff>

<commit_message>
bench: replace 'how minimap2 aligns' slide with 'what we align & how we know'
User: remove the minimap2-internals slide; explain instead how we make the pairwise
alignments / how we know what to align to. New fig_pair: the READS pre-select — a
multimapping read says which loci might be copies (~R candidate group); we then align
ONLY those, copy-vs-copy (minimap2 -cx asm20), never the whole genome -> ~B. Removed
fig6_algo.png/slide; appendix divider updated. Consolidated to canonical deck.

Co-Authored-By: Claude Opus 4.8 (1M context) <noreply@anthropic.com>
Claude-Session: https://claude.ai/code/session_01BwQ1eLGAdbthqL2ALyxxXu
</commit_message>
<xml_diff>
--- a/bench/family_definition_visual.pptx
+++ b/bench/family_definition_visual.pptx
@@ -3206,14 +3206,14 @@
               </a:defRPr>
             </a:pPr>
             <a:r>
-              <a:t>How the alignment works (minimap2's job, not ours; not Needleman–Wunsch)</a:t>
+              <a:t>What do we align — and how do we know what to align to?</a:t>
             </a:r>
           </a:p>
         </p:txBody>
       </p:sp>
       <p:pic>
         <p:nvPicPr>
-          <p:cNvPr id="3" name="Picture 2" descr="fig6_algo.png"/>
+          <p:cNvPr id="3" name="Picture 2" descr="fig_pair.png"/>
           <p:cNvPicPr>
             <a:picLocks noChangeAspect="1"/>
           </p:cNvPicPr>
@@ -3227,8 +3227,8 @@
         </p:blipFill>
         <p:spPr>
           <a:xfrm>
-            <a:off x="425196" y="914400"/>
-            <a:ext cx="11338560" cy="4046663"/>
+            <a:off x="622072" y="914400"/>
+            <a:ext cx="10944807" cy="4892040"/>
           </a:xfrm>
           <a:prstGeom prst="rect">
             <a:avLst/>
@@ -3265,7 +3265,7 @@
               </a:defRPr>
             </a:pPr>
             <a:r>
-              <a:t>minimap2 — not us — does seed–chain–align (minimizer seeds → chaining → banded affine-gap DP). We only consume its output.</a:t>
+              <a:t>The reads pre-select: a multimapping read says which loci might be copies (~R); we align only those, copy-vs-copy (minimap2 asm20) → ~B.</a:t>
             </a:r>
           </a:p>
         </p:txBody>
@@ -4256,8 +4256,8 @@
         </p:blipFill>
         <p:spPr>
           <a:xfrm>
-            <a:off x="2234656" y="914400"/>
-            <a:ext cx="7719639" cy="4892040"/>
+            <a:off x="1801711" y="914400"/>
+            <a:ext cx="8585530" cy="4892040"/>
           </a:xfrm>
           <a:prstGeom prst="rect">
             <a:avLst/>
@@ -4359,7 +4359,7 @@
               </a:defRPr>
             </a:pPr>
             <a:r>
-              <a:t>the alignment algorithm &amp; scoring · error vs. real difference · digesting a read into exons</a:t>
+              <a:t>what we align &amp; how we know what to align to · error vs. real difference · digesting a read into exons</a:t>
             </a:r>
           </a:p>
           <a:p>
@@ -4371,7 +4371,7 @@
               </a:defRPr>
             </a:pPr>
             <a:r>
-              <a:t>What is minimap2's vs ours:  minimap2 does the ALIGNMENT (reads → placements, de, CIGAR — we do not implement an aligner). Our method is everything downstream — the two relations, the graph, the definition.</a:t>
+              <a:t>minimap2 does the ALIGNMENT (reads → placements, de, CIGAR — we do not implement an aligner). Our method is everything downstream — choosing WHAT to align, the two relations, the graph, the definition.</a:t>
             </a:r>
           </a:p>
         </p:txBody>

</xml_diff>